<commit_message>
Minor updated and updated to here page ...
</commit_message>
<xml_diff>
--- a/lectures/Week05_ChainingFinalOverload_Generics/2_Generics_V4.pptx
+++ b/lectures/Week05_ChainingFinalOverload_Generics/2_Generics_V4.pptx
@@ -231,7 +231,7 @@
           <a:p>
             <a:fld id="{8E938536-29D3-49BD-A567-41CAF057586A}" type="datetimeFigureOut">
               <a:rPr lang="en-US" smtClean="0"/>
-              <a:t>9/23/2026</a:t>
+              <a:t>10/21/2026</a:t>
             </a:fld>
             <a:endParaRPr lang="en-US"/>
           </a:p>
@@ -396,7 +396,7 @@
           <a:p>
             <a:fld id="{71559A16-B3AD-4CE2-9A5E-FAAD3C2C27CA}" type="datetimeFigureOut">
               <a:rPr lang="en-US" smtClean="0"/>
-              <a:t>9/23/2026</a:t>
+              <a:t>10/21/2026</a:t>
             </a:fld>
             <a:endParaRPr lang="en-US"/>
           </a:p>
@@ -2078,7 +2078,7 @@
               <a:pPr>
                 <a:defRPr/>
               </a:pPr>
-              <a:t>9/23/2026</a:t>
+              <a:t>10/21/2026</a:t>
             </a:fld>
             <a:endParaRPr lang="en-US"/>
           </a:p>
@@ -7665,7 +7665,7 @@
                   <a:srgbClr val="FF0000"/>
                 </a:solidFill>
               </a:rPr>
-              <a:t>Integer</a:t>
+              <a:t>Integer (int not ok)</a:t>
             </a:r>
           </a:p>
           <a:p>

</xml_diff>